<commit_message>
docs(slides): agregar nota de auditoria sobre coincidencia de causales y facturas fisicas en diapositiva 5
</commit_message>
<xml_diff>
--- a/docs/presentacion_ejecutiva.pptx
+++ b/docs/presentacion_ejecutiva.pptx
@@ -6419,6 +6419,41 @@
           </a:graphicData>
         </a:graphic>
       </p:graphicFrame>
+      <p:sp>
+        <p:nvSpPr>
+          <p:cNvPr id="14" name="TextBox 13"/>
+          <p:cNvSpPr txBox="1"/>
+          <p:nvPr/>
+        </p:nvSpPr>
+        <p:spPr>
+          <a:xfrm>
+            <a:off x="731520" y="6035040"/>
+            <a:ext cx="10698480" cy="365760"/>
+          </a:xfrm>
+          <a:prstGeom prst="rect">
+            <a:avLst/>
+          </a:prstGeom>
+          <a:noFill/>
+        </p:spPr>
+        <p:txBody>
+          <a:bodyPr wrap="none">
+            <a:spAutoFit/>
+          </a:bodyPr>
+          <a:lstStyle/>
+          <a:p>
+            <a:pPr>
+              <a:defRPr sz="950" i="1">
+                <a:solidFill>
+                  <a:srgbClr val="6B6B6B"/>
+                </a:solidFill>
+              </a:defRPr>
+            </a:pPr>
+            <a:r>
+              <a:t>* Nota de auditoría: La suma de causales (19) difiere del total de facturas físicas con discrepancia (18) porque la factura FAC-0042 presenta dos inconsistencias simultáneas (sin asiento contable y fecha de factura vacía).</a:t>
+            </a:r>
+          </a:p>
+        </p:txBody>
+      </p:sp>
     </p:spTree>
   </p:cSld>
   <p:clrMapOvr>

</xml_diff>